<commit_message>
docs(proposal): refresh proposal, deck, and generators for v1.2.4 features
- Project proposal: Quick Capture, dev-watch, digest notification
  sections; desktop app bullets; roadmap status rows; differentiators
- Presentation (marp): self_healing_react agent row, Quick Capture +
  Dev-Watch use cases, status slide lines, dev-watch key command
- generate_pptx.py: agent table row, desktop highlights block, roadmap
  bullets; regenerated NOVA_AI_Technical_Presentation.pptx
- generate_pdf.py: new 9.4 Developer Diagnostics and 9.5 Digest
  Notifications sections; regenerated NOVA_AI_Technical_Proposal.pdf

Co-Authored-By: Claude Code <noreply@anthropic.com>
</commit_message>
<xml_diff>
--- a/docs/proposal/NOVA_AI_Technical_Presentation.pptx
+++ b/docs/proposal/NOVA_AI_Technical_Presentation.pptx
@@ -3890,6 +3890,24 @@
               </a:defRPr>
             </a:pPr>
             <a:r>
+              <a:t>Desktop Highlights:</a:t>
+            </a:r>
+            <a:br/>
+            <a:br/>
+            <a:r>
+              <a:t>  Quick Capture popup: Alt+Space global hotkey (Cmd+Shift+Space on macOS)</a:t>
+            </a:r>
+            <a:br/>
+            <a:r>
+              <a:t>  nova dev-watch: self-healing build/test diagnostics with a Dashboard feed</a:t>
+            </a:r>
+            <a:br/>
+            <a:r>
+              <a:t>  Morning digest: desktop notification on delivery + Windows audio playback</a:t>
+            </a:r>
+            <a:br/>
+            <a:br/>
+            <a:r>
               <a:t>Channel Integrations (15+):</a:t>
             </a:r>
             <a:br/>
@@ -4708,7 +4726,7 @@
               </a:defRPr>
             </a:pPr>
             <a:r>
-              <a:t>8+ agent types</a:t>
+              <a:t>8+ agent types (incl. self-healing)</a:t>
             </a:r>
           </a:p>
           <a:p>
@@ -4789,6 +4807,54 @@
             </a:pPr>
             <a:r>
               <a:t>Desktop app (Tauri)</a:t>
+            </a:r>
+          </a:p>
+          <a:p>
+            <a:pPr>
+              <a:spcAft>
+                <a:spcPts val="600"/>
+              </a:spcAft>
+              <a:defRPr sz="1400">
+                <a:solidFill>
+                  <a:srgbClr val="E0E0E0"/>
+                </a:solidFill>
+                <a:latin typeface="Calibri"/>
+              </a:defRPr>
+            </a:pPr>
+            <a:r>
+              <a:t>Quick Capture popup (Alt+Space)</a:t>
+            </a:r>
+          </a:p>
+          <a:p>
+            <a:pPr>
+              <a:spcAft>
+                <a:spcPts val="600"/>
+              </a:spcAft>
+              <a:defRPr sz="1400">
+                <a:solidFill>
+                  <a:srgbClr val="E0E0E0"/>
+                </a:solidFill>
+                <a:latin typeface="Calibri"/>
+              </a:defRPr>
+            </a:pPr>
+            <a:r>
+              <a:t>dev-watch self-healing diagnostics</a:t>
+            </a:r>
+          </a:p>
+          <a:p>
+            <a:pPr>
+              <a:spcAft>
+                <a:spcPts val="600"/>
+              </a:spcAft>
+              <a:defRPr sz="1400">
+                <a:solidFill>
+                  <a:srgbClr val="E0E0E0"/>
+                </a:solidFill>
+                <a:latin typeface="Calibri"/>
+              </a:defRPr>
+            </a:pPr>
+            <a:r>
+              <a:t>Digest desktop notifications</a:t>
             </a:r>
           </a:p>
           <a:p>
@@ -7115,7 +7181,7 @@
         </p:nvGraphicFramePr>
         <p:xfrm>
           <a:off x="6217920" y="1188720"/>
-          <a:ext cx="6126480" cy="3291840"/>
+          <a:ext cx="6126480" cy="3657600"/>
         </p:xfrm>
         <a:graphic>
           <a:graphicData uri="http://schemas.openxmlformats.org/drawingml/2006/table">
@@ -7439,7 +7505,7 @@
                         </a:defRPr>
                       </a:pPr>
                       <a:r>
-                        <a:t>native_openhands</a:t>
+                        <a:t>self_healing_react</a:t>
                       </a:r>
                     </a:p>
                   </a:txBody>
@@ -7487,7 +7553,7 @@
                         </a:defRPr>
                       </a:pPr>
                       <a:r>
-                        <a:t>CodeAct - writes and executes Python</a:t>
+                        <a:t>ReAct + bounded self-repair loop</a:t>
                       </a:r>
                     </a:p>
                   </a:txBody>
@@ -7513,7 +7579,7 @@
                         </a:defRPr>
                       </a:pPr>
                       <a:r>
-                        <a:t>deep_research</a:t>
+                        <a:t>native_openhands</a:t>
                       </a:r>
                     </a:p>
                   </a:txBody>
@@ -7561,7 +7627,7 @@
                         </a:defRPr>
                       </a:pPr>
                       <a:r>
-                        <a:t>Multi-hop research with citations</a:t>
+                        <a:t>CodeAct - writes and executes Python</a:t>
                       </a:r>
                     </a:p>
                   </a:txBody>
@@ -7587,7 +7653,7 @@
                         </a:defRPr>
                       </a:pPr>
                       <a:r>
-                        <a:t>operative</a:t>
+                        <a:t>deep_research</a:t>
                       </a:r>
                     </a:p>
                   </a:txBody>
@@ -7611,7 +7677,7 @@
                         </a:defRPr>
                       </a:pPr>
                       <a:r>
-                        <a:t>Continuous</a:t>
+                        <a:t>On-demand</a:t>
                       </a:r>
                     </a:p>
                   </a:txBody>
@@ -7635,7 +7701,7 @@
                         </a:defRPr>
                       </a:pPr>
                       <a:r>
-                        <a:t>Persistent agent with state</a:t>
+                        <a:t>Multi-hop research with citations</a:t>
                       </a:r>
                     </a:p>
                   </a:txBody>
@@ -7661,7 +7727,7 @@
                         </a:defRPr>
                       </a:pPr>
                       <a:r>
-                        <a:t>monitor_operative</a:t>
+                        <a:t>operative</a:t>
                       </a:r>
                     </a:p>
                   </a:txBody>
@@ -7709,7 +7775,7 @@
                         </a:defRPr>
                       </a:pPr>
                       <a:r>
-                        <a:t>Long-horizon monitoring</a:t>
+                        <a:t>Persistent agent with state</a:t>
                       </a:r>
                     </a:p>
                   </a:txBody>
@@ -7735,13 +7801,87 @@
                         </a:defRPr>
                       </a:pPr>
                       <a:r>
+                        <a:t>monitor_operative</a:t>
+                      </a:r>
+                    </a:p>
+                  </a:txBody>
+                  <a:tcPr>
+                    <a:solidFill>
+                      <a:srgbClr val="1A1A3E"/>
+                    </a:solidFill>
+                  </a:tcPr>
+                </a:tc>
+                <a:tc>
+                  <a:txBody>
+                    <a:bodyPr/>
+                    <a:lstStyle/>
+                    <a:p>
+                      <a:pPr>
+                        <a:defRPr sz="1300">
+                          <a:solidFill>
+                            <a:srgbClr val="E0E0E0"/>
+                          </a:solidFill>
+                          <a:latin typeface="Calibri"/>
+                        </a:defRPr>
+                      </a:pPr>
+                      <a:r>
+                        <a:t>Continuous</a:t>
+                      </a:r>
+                    </a:p>
+                  </a:txBody>
+                  <a:tcPr>
+                    <a:solidFill>
+                      <a:srgbClr val="1A1A3E"/>
+                    </a:solidFill>
+                  </a:tcPr>
+                </a:tc>
+                <a:tc>
+                  <a:txBody>
+                    <a:bodyPr/>
+                    <a:lstStyle/>
+                    <a:p>
+                      <a:pPr>
+                        <a:defRPr sz="1300">
+                          <a:solidFill>
+                            <a:srgbClr val="E0E0E0"/>
+                          </a:solidFill>
+                          <a:latin typeface="Calibri"/>
+                        </a:defRPr>
+                      </a:pPr>
+                      <a:r>
+                        <a:t>Long-horizon monitoring</a:t>
+                      </a:r>
+                    </a:p>
+                  </a:txBody>
+                  <a:tcPr>
+                    <a:solidFill>
+                      <a:srgbClr val="1A1A3E"/>
+                    </a:solidFill>
+                  </a:tcPr>
+                </a:tc>
+              </a:tr>
+              <a:tr h="365760">
+                <a:tc>
+                  <a:txBody>
+                    <a:bodyPr/>
+                    <a:lstStyle/>
+                    <a:p>
+                      <a:pPr>
+                        <a:defRPr sz="1300">
+                          <a:solidFill>
+                            <a:srgbClr val="E0E0E0"/>
+                          </a:solidFill>
+                          <a:latin typeface="Calibri"/>
+                        </a:defRPr>
+                      </a:pPr>
+                      <a:r>
                         <a:t>proactive_agent</a:t>
                       </a:r>
                     </a:p>
                   </a:txBody>
                   <a:tcPr>
                     <a:solidFill>
-                      <a:srgbClr val="1A1A3E"/>
+                      <a:srgbClr val="141028"/>
                     </a:solidFill>
                   </a:tcPr>
                 </a:tc>
@@ -7765,7 +7905,7 @@
                   </a:txBody>
                   <a:tcPr>
                     <a:solidFill>
-                      <a:srgbClr val="1A1A3E"/>
+                      <a:srgbClr val="141028"/>
                     </a:solidFill>
                   </a:tcPr>
                 </a:tc>
@@ -7789,7 +7929,7 @@
                   </a:txBody>
                   <a:tcPr>
                     <a:solidFill>
-                      <a:srgbClr val="1A1A3E"/>
+                      <a:srgbClr val="141028"/>
                     </a:solidFill>
                   </a:tcPr>
                 </a:tc>

</xml_diff>